<commit_message>
Show the mastery benchmark on the curriculum slide and keep game screenshots full-bleed.
The 70% line is an instructional benchmark, not a completion threshold. Full-bleed screenshots keep the UI as large as the 16:9 frame allows.

Co-authored-by: piaattufts <piaattufts@users.noreply.github.com>
</commit_message>
<xml_diff>
--- a/docs/presentation/fie26-tripathi.pptx
+++ b/docs/presentation/fie26-tripathi.pptx
@@ -7172,14 +7172,54 @@
         </p:blipFill>
         <p:spPr>
           <a:xfrm>
-            <a:off x="0" y="0"/>
-            <a:ext cx="12191999" cy="6857999"/>
+            <a:off x="770636" y="137160"/>
+            <a:ext cx="10647680" cy="5989320"/>
           </a:xfrm>
           <a:prstGeom prst="rect">
             <a:avLst/>
           </a:prstGeom>
         </p:spPr>
       </p:pic>
+      <p:sp>
+        <p:nvSpPr>
+          <p:cNvPr id="3" name="TextBox 2"/>
+          <p:cNvSpPr txBox="1"/>
+          <p:nvPr/>
+        </p:nvSpPr>
+        <p:spPr>
+          <a:xfrm>
+            <a:off x="365760" y="6263640"/>
+            <a:ext cx="11430000" cy="411480"/>
+          </a:xfrm>
+          <a:prstGeom prst="rect">
+            <a:avLst/>
+          </a:prstGeom>
+          <a:noFill/>
+        </p:spPr>
+        <p:txBody>
+          <a:bodyPr wrap="square" lIns="0" rIns="0" tIns="0" bIns="0" anchor="ctr"/>
+          <a:lstStyle/>
+          <a:p>
+            <a:pPr algn="ctr">
+              <a:spcBef>
+                <a:spcPts val="0"/>
+              </a:spcBef>
+              <a:spcAft>
+                <a:spcPts val="0"/>
+              </a:spcAft>
+            </a:pPr>
+            <a:r>
+              <a:rPr sz="2000" b="1">
+                <a:solidFill>
+                  <a:srgbClr val="142033"/>
+                </a:solidFill>
+                <a:latin typeface="Calibri"/>
+              </a:rPr>
+              <a:t>Later tiers open at a 70% instructional mastery benchmark.</a:t>
+            </a:r>
+          </a:p>
+        </p:txBody>
+      </p:sp>
     </p:spTree>
   </p:cSld>
   <p:clrMapOvr>

</xml_diff>